<commit_message>
last modification to presentation
</commit_message>
<xml_diff>
--- a/simuladores_1/presentacion/delta_radiomics_presentation.pptx
+++ b/simuladores_1/presentacion/delta_radiomics_presentation.pptx
@@ -4,16 +4,16 @@
   <p:sldMasterIdLst>
     <p:sldMasterId id="2147483648" r:id="rId1"/>
   </p:sldMasterIdLst>
+  <p:notesMasterIdLst>
+    <p:notesMasterId r:id="rId6"/>
+  </p:notesMasterIdLst>
   <p:sldIdLst>
     <p:sldId id="256" r:id="rId2"/>
     <p:sldId id="257" r:id="rId3"/>
     <p:sldId id="258" r:id="rId4"/>
     <p:sldId id="259" r:id="rId5"/>
   </p:sldIdLst>
-  <p:notesMasterIdLst>
-    <p:notesMasterId r:id="rId6"/>
-  </p:notesMasterIdLst>
-  <p:sldSz cx="9144000" cy="5143500"/>
+  <p:sldSz cx="9144000" cy="5143500" type="screen16x9"/>
   <p:notesSz cx="5143500" cy="9144000"/>
   <p:defaultTextStyle>
     <a:lvl1pPr marL="0" algn="l" defTabSz="914400" rtl="0" eaLnBrk="1" latinLnBrk="0" hangingPunct="1">
@@ -107,6 +107,11 @@
       </a:defRPr>
     </a:lvl9pPr>
   </p:defaultTextStyle>
+  <p:extLst>
+    <p:ext uri="{EFAFB233-063F-42B5-8137-9DF3F51BA10A}">
+      <p15:sldGuideLst xmlns:p15="http://schemas.microsoft.com/office/powerpoint/2012/main"/>
+    </p:ext>
+  </p:extLst>
 </p:presentation>
 </file>
 
@@ -132,234 +137,10 @@
           <a:chExt cx="0" cy="0"/>
         </a:xfrm>
       </p:grpSpPr>
-      <p:sp>
-        <p:nvSpPr>
-          <p:cNvPr id="2" name="Header Placeholder 1"/>
-          <p:cNvSpPr>
-            <a:spLocks noGrp="1"/>
-          </p:cNvSpPr>
-          <p:nvPr>
-            <p:ph type="hdr" sz="quarter"/>
-          </p:nvPr>
-        </p:nvSpPr>
-        <p:spPr>
-          <a:xfrm>
-            <a:off x="0" y="0"/>
-            <a:ext cx="2971800" cy="458788"/>
-          </a:xfrm>
-          <a:prstGeom prst="rect">
-            <a:avLst/>
-          </a:prstGeom>
-        </p:spPr>
-        <p:txBody>
-          <a:bodyPr vert="horz" lIns="91440" tIns="45720" rIns="91440" bIns="45720" rtlCol="0"/>
-          <a:lstStyle>
-            <a:lvl1pPr algn="l">
-              <a:defRPr sz="1200"/>
-            </a:lvl1pPr>
-          </a:lstStyle>
-          <a:p>
-            <a:endParaRPr lang="en-US"/>
-          </a:p>
-        </p:txBody>
-      </p:sp>
-      <p:sp>
-        <p:nvSpPr>
-          <p:cNvPr id="3" name="Date Placeholder 2"/>
-          <p:cNvSpPr>
-            <a:spLocks noGrp="1"/>
-          </p:cNvSpPr>
-          <p:nvPr>
-            <p:ph type="dt" idx="1"/>
-          </p:nvPr>
-        </p:nvSpPr>
-        <p:spPr>
-          <a:xfrm>
-            <a:off x="3884613" y="0"/>
-            <a:ext cx="2971800" cy="458788"/>
-          </a:xfrm>
-          <a:prstGeom prst="rect">
-            <a:avLst/>
-          </a:prstGeom>
-        </p:spPr>
-        <p:txBody>
-          <a:bodyPr vert="horz" lIns="91440" tIns="45720" rIns="91440" bIns="45720" rtlCol="0"/>
-          <a:lstStyle>
-            <a:lvl1pPr algn="r">
-              <a:defRPr sz="1200"/>
-            </a:lvl1pPr>
-          </a:lstStyle>
-          <a:p>
-            <a:fld id="{5282F153-3F37-0F45-9E97-73ACFA13230C}" type="datetimeFigureOut">
-              <a:rPr lang="en-US"/>
-              <a:t>7/23/19</a:t>
-            </a:fld>
-            <a:endParaRPr lang="en-US"/>
-          </a:p>
-        </p:txBody>
-      </p:sp>
-      <p:sp>
-        <p:nvSpPr>
-          <p:cNvPr id="4" name="Slide Image Placeholder 3"/>
-          <p:cNvSpPr>
-            <a:spLocks noGrp="1" noRot="1" noChangeAspect="1"/>
-          </p:cNvSpPr>
-          <p:nvPr>
-            <p:ph type="sldImg" idx="2"/>
-          </p:nvPr>
-        </p:nvSpPr>
-        <p:spPr>
-          <a:xfrm>
-            <a:off x="685800" y="1143000"/>
-            <a:ext cx="5486400" cy="3086100"/>
-          </a:xfrm>
-          <a:prstGeom prst="rect">
-            <a:avLst/>
-          </a:prstGeom>
-          <a:noFill/>
-          <a:ln w="12700">
-            <a:solidFill>
-              <a:prstClr val="black"/>
-            </a:solidFill>
-          </a:ln>
-        </p:spPr>
-        <p:txBody>
-          <a:bodyPr vert="horz" lIns="91440" tIns="45720" rIns="91440" bIns="45720" rtlCol="0" anchor="ctr"/>
-          <a:lstStyle/>
-          <a:p>
-            <a:endParaRPr lang="en-US"/>
-          </a:p>
-        </p:txBody>
-      </p:sp>
-      <p:sp>
-        <p:nvSpPr>
-          <p:cNvPr id="5" name="Notes Placeholder 4"/>
-          <p:cNvSpPr>
-            <a:spLocks noGrp="1"/>
-          </p:cNvSpPr>
-          <p:nvPr>
-            <p:ph type="body" sz="quarter" idx="3"/>
-          </p:nvPr>
-        </p:nvSpPr>
-        <p:spPr>
-          <a:xfrm>
-            <a:off x="685800" y="4400550"/>
-            <a:ext cx="5486400" cy="3600450"/>
-          </a:xfrm>
-          <a:prstGeom prst="rect">
-            <a:avLst/>
-          </a:prstGeom>
-        </p:spPr>
-        <p:txBody>
-          <a:bodyPr vert="horz" lIns="91440" tIns="45720" rIns="91440" bIns="45720" rtlCol="0"/>
-          <a:lstStyle/>
-          <a:p>
-            <a:pPr lvl="0"/>
-            <a:r>
-              <a:rPr lang="en-US"/>
-              <a:t>Click to edit Master text styles</a:t>
-            </a:r>
-          </a:p>
-          <a:p>
-            <a:pPr lvl="1"/>
-            <a:r>
-              <a:rPr lang="en-US"/>
-              <a:t>Second level</a:t>
-            </a:r>
-          </a:p>
-          <a:p>
-            <a:pPr lvl="2"/>
-            <a:r>
-              <a:rPr lang="en-US"/>
-              <a:t>Third level</a:t>
-            </a:r>
-          </a:p>
-          <a:p>
-            <a:pPr lvl="3"/>
-            <a:r>
-              <a:rPr lang="en-US"/>
-              <a:t>Fourth level</a:t>
-            </a:r>
-          </a:p>
-          <a:p>
-            <a:pPr lvl="4"/>
-            <a:r>
-              <a:rPr lang="en-US"/>
-              <a:t>Fifth level</a:t>
-            </a:r>
-          </a:p>
-        </p:txBody>
-      </p:sp>
-      <p:sp>
-        <p:nvSpPr>
-          <p:cNvPr id="6" name="Footer Placeholder 5"/>
-          <p:cNvSpPr>
-            <a:spLocks noGrp="1"/>
-          </p:cNvSpPr>
-          <p:nvPr>
-            <p:ph type="ftr" sz="quarter" idx="4"/>
-          </p:nvPr>
-        </p:nvSpPr>
-        <p:spPr>
-          <a:xfrm>
-            <a:off x="0" y="8685213"/>
-            <a:ext cx="2971800" cy="458787"/>
-          </a:xfrm>
-          <a:prstGeom prst="rect">
-            <a:avLst/>
-          </a:prstGeom>
-        </p:spPr>
-        <p:txBody>
-          <a:bodyPr vert="horz" lIns="91440" tIns="45720" rIns="91440" bIns="45720" rtlCol="0" anchor="b"/>
-          <a:lstStyle>
-            <a:lvl1pPr algn="l">
-              <a:defRPr sz="1200"/>
-            </a:lvl1pPr>
-          </a:lstStyle>
-          <a:p>
-            <a:endParaRPr lang="en-US"/>
-          </a:p>
-        </p:txBody>
-      </p:sp>
-      <p:sp>
-        <p:nvSpPr>
-          <p:cNvPr id="7" name="Slide Number Placeholder 6"/>
-          <p:cNvSpPr>
-            <a:spLocks noGrp="1"/>
-          </p:cNvSpPr>
-          <p:nvPr>
-            <p:ph type="sldNum" sz="quarter" idx="5"/>
-          </p:nvPr>
-        </p:nvSpPr>
-        <p:spPr>
-          <a:xfrm>
-            <a:off x="3884613" y="8685213"/>
-            <a:ext cx="2971800" cy="458787"/>
-          </a:xfrm>
-          <a:prstGeom prst="rect">
-            <a:avLst/>
-          </a:prstGeom>
-        </p:spPr>
-        <p:txBody>
-          <a:bodyPr vert="horz" lIns="91440" tIns="45720" rIns="91440" bIns="45720" rtlCol="0" anchor="b"/>
-          <a:lstStyle>
-            <a:lvl1pPr algn="r">
-              <a:defRPr sz="1200"/>
-            </a:lvl1pPr>
-          </a:lstStyle>
-          <a:p>
-            <a:fld id="{CE5E9CC1-C706-0F49-92D6-E571CC5EEA8F}" type="slidenum">
-              <a:rPr lang="en-US"/>
-              <a:t>‹#›</a:t>
-            </a:fld>
-            <a:endParaRPr lang="en-US"/>
-          </a:p>
-        </p:txBody>
-      </p:sp>
     </p:spTree>
     <p:extLst>
       <p:ext uri="{BB962C8B-B14F-4D97-AF65-F5344CB8AC3E}">
-        <p14:creationId xmlns:p14="http://schemas.microsoft.com/office/powerpoint/2010/main" val="1024086991"/>
+        <p14:creationId xmlns:p14="http://schemas.microsoft.com/office/powerpoint/2010/main" val="467268170"/>
       </p:ext>
     </p:extLst>
   </p:cSld>
@@ -503,10 +284,6 @@
           <a:bodyPr/>
           <a:lstStyle/>
           <a:p>
-            <a:r>
-              <a:rPr lang="en-US" dirty="0"/>
-              <a:t/>
-            </a:r>
             <a:endParaRPr lang="en-US" dirty="0"/>
           </a:p>
         </p:txBody>
@@ -591,10 +368,6 @@
           <a:bodyPr/>
           <a:lstStyle/>
           <a:p>
-            <a:r>
-              <a:rPr lang="en-US" dirty="0"/>
-              <a:t/>
-            </a:r>
             <a:endParaRPr lang="en-US" dirty="0"/>
           </a:p>
         </p:txBody>
@@ -679,10 +452,6 @@
           <a:bodyPr/>
           <a:lstStyle/>
           <a:p>
-            <a:r>
-              <a:rPr lang="en-US" dirty="0"/>
-              <a:t/>
-            </a:r>
             <a:endParaRPr lang="en-US" dirty="0"/>
           </a:p>
         </p:txBody>
@@ -767,10 +536,6 @@
           <a:bodyPr/>
           <a:lstStyle/>
           <a:p>
-            <a:r>
-              <a:rPr lang="en-US" dirty="0"/>
-              <a:t/>
-            </a:r>
             <a:endParaRPr lang="en-US" dirty="0"/>
           </a:p>
         </p:txBody>
@@ -844,6 +609,11 @@
 <file path=ppt/slideMasters/slideMaster1.xml><?xml version="1.0" encoding="utf-8"?>
 <p:sldMaster xmlns:a="http://schemas.openxmlformats.org/drawingml/2006/main" xmlns:r="http://schemas.openxmlformats.org/officeDocument/2006/relationships" xmlns:p="http://schemas.openxmlformats.org/presentationml/2006/main">
   <p:cSld>
+    <p:bg>
+      <p:bgRef idx="1001">
+        <a:schemeClr val="bg1"/>
+      </p:bgRef>
+    </p:bg>
     <p:spTree>
       <p:nvGrpSpPr>
         <p:cNvPr id="1" name=""/>
@@ -1126,6 +896,7 @@
         <a:solidFill>
           <a:srgbClr val="1A2440"/>
         </a:solidFill>
+        <a:effectLst/>
       </p:bgPr>
     </p:bg>
     <p:spTree>
@@ -1213,7 +984,7 @@
           <a:bodyPr wrap="square" lIns="0" tIns="0" rIns="0" bIns="0" rtlCol="0" anchor="ctr"/>
           <a:lstStyle/>
           <a:p>
-            <a:pPr algn="ctr" indent="0" marL="0">
+            <a:pPr marL="0" indent="0" algn="ctr">
               <a:buNone/>
             </a:pPr>
             <a:r>
@@ -1252,7 +1023,7 @@
           <a:bodyPr wrap="square" rtlCol="0" anchor="ctr"/>
           <a:lstStyle/>
           <a:p>
-            <a:pPr indent="0" marL="0">
+            <a:pPr marL="0" indent="0">
               <a:buNone/>
             </a:pPr>
             <a:r>
@@ -1291,7 +1062,7 @@
           <a:bodyPr wrap="square" rtlCol="0" anchor="ctr"/>
           <a:lstStyle/>
           <a:p>
-            <a:pPr indent="0" marL="0">
+            <a:pPr marL="0" indent="0">
               <a:buNone/>
             </a:pPr>
             <a:r>
@@ -1353,7 +1124,7 @@
           <a:bodyPr wrap="square" lIns="0" tIns="0" rIns="0" bIns="0" rtlCol="0" anchor="b"/>
           <a:lstStyle/>
           <a:p>
-            <a:pPr algn="ctr" indent="0" marL="0">
+            <a:pPr marL="0" indent="0" algn="ctr">
               <a:buNone/>
             </a:pPr>
             <a:r>
@@ -1392,7 +1163,7 @@
           <a:bodyPr wrap="square" rtlCol="0" anchor="t"/>
           <a:lstStyle/>
           <a:p>
-            <a:pPr algn="ctr" indent="0" marL="0">
+            <a:pPr marL="0" indent="0" algn="ctr">
               <a:buNone/>
             </a:pPr>
             <a:r>
@@ -1431,7 +1202,7 @@
           <a:bodyPr wrap="square" lIns="0" tIns="0" rIns="0" bIns="0" rtlCol="0" anchor="b"/>
           <a:lstStyle/>
           <a:p>
-            <a:pPr algn="ctr" indent="0" marL="0">
+            <a:pPr marL="0" indent="0" algn="ctr">
               <a:buNone/>
             </a:pPr>
             <a:r>
@@ -1470,7 +1241,7 @@
           <a:bodyPr wrap="square" rtlCol="0" anchor="t"/>
           <a:lstStyle/>
           <a:p>
-            <a:pPr algn="ctr" indent="0" marL="0">
+            <a:pPr marL="0" indent="0" algn="ctr">
               <a:buNone/>
             </a:pPr>
             <a:r>
@@ -1509,7 +1280,7 @@
           <a:bodyPr wrap="square" lIns="0" tIns="0" rIns="0" bIns="0" rtlCol="0" anchor="b"/>
           <a:lstStyle/>
           <a:p>
-            <a:pPr algn="ctr" indent="0" marL="0">
+            <a:pPr marL="0" indent="0" algn="ctr">
               <a:buNone/>
             </a:pPr>
             <a:r>
@@ -1548,7 +1319,7 @@
           <a:bodyPr wrap="square" rtlCol="0" anchor="t"/>
           <a:lstStyle/>
           <a:p>
-            <a:pPr algn="ctr" indent="0" marL="0">
+            <a:pPr marL="0" indent="0" algn="ctr">
               <a:buNone/>
             </a:pPr>
             <a:r>
@@ -1658,7 +1429,7 @@
           <a:bodyPr wrap="square" rtlCol="0" anchor="ctr"/>
           <a:lstStyle/>
           <a:p>
-            <a:pPr indent="0" marL="0">
+            <a:pPr marL="0" indent="0">
               <a:buNone/>
             </a:pPr>
             <a:r>
@@ -1692,6 +1463,7 @@
         <a:solidFill>
           <a:srgbClr val="EEF1F8"/>
         </a:solidFill>
+        <a:effectLst/>
       </p:bgPr>
     </p:bg>
     <p:spTree>
@@ -1729,7 +1501,7 @@
           <a:bodyPr wrap="square" rtlCol="0" anchor="ctr"/>
           <a:lstStyle/>
           <a:p>
-            <a:pPr indent="0" marL="0">
+            <a:pPr marL="0" indent="0">
               <a:buNone/>
             </a:pPr>
             <a:r>
@@ -1771,7 +1543,7 @@
             <a:prstDash val="solid"/>
           </a:ln>
           <a:effectLst>
-            <a:outerShdw sx="100000" sy="100000" kx="0" ky="0" algn="bl" rotWithShape="0" blurRad="101600" dist="25400" dir="8100000">
+            <a:outerShdw blurRad="101600" dist="25400" dir="8100000" algn="bl" rotWithShape="0">
               <a:srgbClr val="000000">
                 <a:alpha val="9000"/>
               </a:srgbClr>
@@ -1800,11 +1572,11 @@
           <a:bodyPr wrap="square" rtlCol="0" anchor="ctr"/>
           <a:lstStyle/>
           <a:p>
-            <a:pPr indent="0" marL="0">
-              <a:buNone/>
-            </a:pPr>
-            <a:r>
-              <a:rPr lang="en-US" sz="1100" b="1" spc="300" kern="0" dirty="0">
+            <a:pPr marL="0" indent="0">
+              <a:buNone/>
+            </a:pPr>
+            <a:r>
+              <a:rPr lang="en-US" sz="1100" b="1" kern="0" spc="300" dirty="0">
                 <a:solidFill>
                   <a:srgbClr val="009E84"/>
                 </a:solidFill>
@@ -1857,7 +1629,7 @@
             <a:endParaRPr lang="en-US" sz="1300" dirty="0"/>
           </a:p>
           <a:p>
-            <a:pPr indent="0" marL="0">
+            <a:pPr marL="0" indent="0">
               <a:buNone/>
             </a:pPr>
             <a:endParaRPr lang="en-US" sz="1300" dirty="0"/>
@@ -1881,7 +1653,7 @@
             <a:endParaRPr lang="en-US" sz="1300" dirty="0"/>
           </a:p>
           <a:p>
-            <a:pPr indent="0" marL="0">
+            <a:pPr marL="0" indent="0">
               <a:buNone/>
             </a:pPr>
             <a:endParaRPr lang="en-US" sz="1300" dirty="0"/>
@@ -1905,7 +1677,7 @@
             <a:endParaRPr lang="en-US" sz="1300" dirty="0"/>
           </a:p>
           <a:p>
-            <a:pPr indent="0" marL="0">
+            <a:pPr marL="0" indent="0">
               <a:buNone/>
             </a:pPr>
             <a:endParaRPr lang="en-US" sz="1300" dirty="0"/>
@@ -1954,7 +1726,7 @@
             <a:prstDash val="solid"/>
           </a:ln>
           <a:effectLst>
-            <a:outerShdw sx="100000" sy="100000" kx="0" ky="0" algn="bl" rotWithShape="0" blurRad="101600" dist="25400" dir="8100000">
+            <a:outerShdw blurRad="101600" dist="25400" dir="8100000" algn="bl" rotWithShape="0">
               <a:srgbClr val="000000">
                 <a:alpha val="9000"/>
               </a:srgbClr>
@@ -1983,11 +1755,11 @@
           <a:bodyPr wrap="square" rtlCol="0" anchor="ctr"/>
           <a:lstStyle/>
           <a:p>
-            <a:pPr indent="0" marL="0">
-              <a:buNone/>
-            </a:pPr>
-            <a:r>
-              <a:rPr lang="en-US" sz="1100" b="1" spc="300" kern="0" dirty="0">
+            <a:pPr marL="0" indent="0">
+              <a:buNone/>
+            </a:pPr>
+            <a:r>
+              <a:rPr lang="en-US" sz="1100" b="1" kern="0" spc="300" dirty="0">
                 <a:solidFill>
                   <a:srgbClr val="009E84"/>
                 </a:solidFill>
@@ -2022,7 +1794,7 @@
           <a:bodyPr wrap="square" lIns="0" tIns="0" rIns="0" bIns="0" rtlCol="0" anchor="ctr"/>
           <a:lstStyle/>
           <a:p>
-            <a:pPr algn="ctr" indent="0" marL="0">
+            <a:pPr marL="0" indent="0" algn="ctr">
               <a:buNone/>
             </a:pPr>
             <a:r>
@@ -2061,7 +1833,7 @@
           <a:bodyPr wrap="square" lIns="0" tIns="0" rIns="0" bIns="0" rtlCol="0" anchor="ctr"/>
           <a:lstStyle/>
           <a:p>
-            <a:pPr algn="ctr" indent="0" marL="0">
+            <a:pPr marL="0" indent="0" algn="ctr">
               <a:buNone/>
             </a:pPr>
             <a:r>
@@ -2100,7 +1872,7 @@
           <a:bodyPr wrap="square" lIns="0" tIns="0" rIns="0" bIns="0" rtlCol="0" anchor="ctr"/>
           <a:lstStyle/>
           <a:p>
-            <a:pPr algn="ctr" indent="0" marL="0">
+            <a:pPr marL="0" indent="0" algn="ctr">
               <a:buNone/>
             </a:pPr>
             <a:r>
@@ -2139,7 +1911,7 @@
           <a:bodyPr wrap="square" lIns="0" tIns="0" rIns="0" bIns="0" rtlCol="0" anchor="ctr"/>
           <a:lstStyle/>
           <a:p>
-            <a:pPr algn="ctr" indent="0" marL="0">
+            <a:pPr marL="0" indent="0" algn="ctr">
               <a:buNone/>
             </a:pPr>
             <a:r>
@@ -2178,7 +1950,7 @@
           <a:bodyPr wrap="square" lIns="0" tIns="0" rIns="0" bIns="0" rtlCol="0" anchor="ctr"/>
           <a:lstStyle/>
           <a:p>
-            <a:pPr algn="ctr" indent="0" marL="0">
+            <a:pPr marL="0" indent="0" algn="ctr">
               <a:buNone/>
             </a:pPr>
             <a:r>
@@ -2217,7 +1989,7 @@
           <a:bodyPr wrap="square" lIns="0" tIns="0" rIns="0" bIns="0" rtlCol="0" anchor="ctr"/>
           <a:lstStyle/>
           <a:p>
-            <a:pPr algn="ctr" indent="0" marL="0">
+            <a:pPr marL="0" indent="0" algn="ctr">
               <a:buNone/>
             </a:pPr>
             <a:r>
@@ -2256,7 +2028,7 @@
           <a:bodyPr wrap="square" lIns="0" tIns="0" rIns="0" bIns="0" rtlCol="0" anchor="ctr"/>
           <a:lstStyle/>
           <a:p>
-            <a:pPr algn="ctr" indent="0" marL="0">
+            <a:pPr marL="0" indent="0" algn="ctr">
               <a:buNone/>
             </a:pPr>
             <a:r>
@@ -2295,7 +2067,7 @@
           <a:bodyPr wrap="square" lIns="0" tIns="0" rIns="0" bIns="0" rtlCol="0" anchor="ctr"/>
           <a:lstStyle/>
           <a:p>
-            <a:pPr algn="ctr" indent="0" marL="0">
+            <a:pPr marL="0" indent="0" algn="ctr">
               <a:buNone/>
             </a:pPr>
             <a:r>
@@ -2334,7 +2106,7 @@
           <a:bodyPr wrap="square" lIns="0" tIns="0" rIns="0" bIns="0" rtlCol="0" anchor="ctr"/>
           <a:lstStyle/>
           <a:p>
-            <a:pPr algn="ctr" indent="0" marL="0">
+            <a:pPr marL="0" indent="0" algn="ctr">
               <a:buNone/>
             </a:pPr>
             <a:r>
@@ -2368,6 +2140,7 @@
         <a:solidFill>
           <a:srgbClr val="FFFFFF"/>
         </a:solidFill>
+        <a:effectLst/>
       </p:bgPr>
     </p:bg>
     <p:spTree>
@@ -2405,7 +2178,7 @@
           <a:bodyPr wrap="square" rtlCol="0" anchor="ctr"/>
           <a:lstStyle/>
           <a:p>
-            <a:pPr indent="0" marL="0">
+            <a:pPr marL="0" indent="0">
               <a:buNone/>
             </a:pPr>
             <a:r>
@@ -2447,7 +2220,7 @@
             <a:prstDash val="solid"/>
           </a:ln>
           <a:effectLst>
-            <a:outerShdw sx="100000" sy="100000" kx="0" ky="0" algn="bl" rotWithShape="0" blurRad="101600" dist="25400" dir="8100000">
+            <a:outerShdw blurRad="101600" dist="25400" dir="8100000" algn="bl" rotWithShape="0">
               <a:srgbClr val="000000">
                 <a:alpha val="9000"/>
               </a:srgbClr>
@@ -2526,7 +2299,7 @@
           <a:bodyPr wrap="square" lIns="0" tIns="0" rIns="0" bIns="0" rtlCol="0" anchor="ctr"/>
           <a:lstStyle/>
           <a:p>
-            <a:pPr algn="ctr" indent="0" marL="0">
+            <a:pPr marL="0" indent="0" algn="ctr">
               <a:buNone/>
             </a:pPr>
             <a:r>
@@ -2565,11 +2338,11 @@
           <a:bodyPr wrap="square" rtlCol="0" anchor="ctr"/>
           <a:lstStyle/>
           <a:p>
-            <a:pPr algn="ctr" indent="0" marL="0">
-              <a:buNone/>
-            </a:pPr>
-            <a:r>
-              <a:rPr lang="en-US" sz="1000" b="1" spc="300" kern="0" dirty="0">
+            <a:pPr marL="0" indent="0" algn="ctr">
+              <a:buNone/>
+            </a:pPr>
+            <a:r>
+              <a:rPr lang="en-US" sz="1000" b="1" kern="0" spc="300" dirty="0">
                 <a:solidFill>
                   <a:srgbClr val="2E70D8"/>
                 </a:solidFill>
@@ -2604,7 +2377,7 @@
           <a:bodyPr wrap="square" rtlCol="0" anchor="ctr"/>
           <a:lstStyle/>
           <a:p>
-            <a:pPr algn="ctr" indent="0" marL="0">
+            <a:pPr marL="0" indent="0" algn="ctr">
               <a:buNone/>
             </a:pPr>
             <a:r>
@@ -2740,7 +2513,7 @@
             <a:prstDash val="solid"/>
           </a:ln>
           <a:effectLst>
-            <a:outerShdw sx="100000" sy="100000" kx="0" ky="0" algn="bl" rotWithShape="0" blurRad="101600" dist="25400" dir="8100000">
+            <a:outerShdw blurRad="101600" dist="25400" dir="8100000" algn="bl" rotWithShape="0">
               <a:srgbClr val="000000">
                 <a:alpha val="9000"/>
               </a:srgbClr>
@@ -2819,7 +2592,7 @@
           <a:bodyPr wrap="square" lIns="0" tIns="0" rIns="0" bIns="0" rtlCol="0" anchor="ctr"/>
           <a:lstStyle/>
           <a:p>
-            <a:pPr algn="ctr" indent="0" marL="0">
+            <a:pPr marL="0" indent="0" algn="ctr">
               <a:buNone/>
             </a:pPr>
             <a:r>
@@ -2858,11 +2631,11 @@
           <a:bodyPr wrap="square" rtlCol="0" anchor="ctr"/>
           <a:lstStyle/>
           <a:p>
-            <a:pPr algn="ctr" indent="0" marL="0">
-              <a:buNone/>
-            </a:pPr>
-            <a:r>
-              <a:rPr lang="en-US" sz="1000" b="1" spc="300" kern="0" dirty="0">
+            <a:pPr marL="0" indent="0" algn="ctr">
+              <a:buNone/>
+            </a:pPr>
+            <a:r>
+              <a:rPr lang="en-US" sz="1000" b="1" kern="0" spc="300" dirty="0">
                 <a:solidFill>
                   <a:srgbClr val="009E84"/>
                 </a:solidFill>
@@ -2897,7 +2670,7 @@
           <a:bodyPr wrap="square" rtlCol="0" anchor="ctr"/>
           <a:lstStyle/>
           <a:p>
-            <a:pPr algn="ctr" indent="0" marL="0">
+            <a:pPr marL="0" indent="0" algn="ctr">
               <a:buNone/>
             </a:pPr>
             <a:r>
@@ -3033,7 +2806,7 @@
             <a:prstDash val="solid"/>
           </a:ln>
           <a:effectLst>
-            <a:outerShdw sx="100000" sy="100000" kx="0" ky="0" algn="bl" rotWithShape="0" blurRad="101600" dist="25400" dir="8100000">
+            <a:outerShdw blurRad="101600" dist="25400" dir="8100000" algn="bl" rotWithShape="0">
               <a:srgbClr val="000000">
                 <a:alpha val="9000"/>
               </a:srgbClr>
@@ -3112,7 +2885,7 @@
           <a:bodyPr wrap="square" lIns="0" tIns="0" rIns="0" bIns="0" rtlCol="0" anchor="ctr"/>
           <a:lstStyle/>
           <a:p>
-            <a:pPr algn="ctr" indent="0" marL="0">
+            <a:pPr marL="0" indent="0" algn="ctr">
               <a:buNone/>
             </a:pPr>
             <a:r>
@@ -3151,11 +2924,11 @@
           <a:bodyPr wrap="square" rtlCol="0" anchor="ctr"/>
           <a:lstStyle/>
           <a:p>
-            <a:pPr algn="ctr" indent="0" marL="0">
-              <a:buNone/>
-            </a:pPr>
-            <a:r>
-              <a:rPr lang="en-US" sz="1000" b="1" spc="300" kern="0" dirty="0">
+            <a:pPr marL="0" indent="0" algn="ctr">
+              <a:buNone/>
+            </a:pPr>
+            <a:r>
+              <a:rPr lang="en-US" sz="1000" b="1" kern="0" spc="300" dirty="0">
                 <a:solidFill>
                   <a:srgbClr val="18A858"/>
                 </a:solidFill>
@@ -3190,7 +2963,7 @@
           <a:bodyPr wrap="square" rtlCol="0" anchor="ctr"/>
           <a:lstStyle/>
           <a:p>
-            <a:pPr algn="ctr" indent="0" marL="0">
+            <a:pPr marL="0" indent="0" algn="ctr">
               <a:buNone/>
             </a:pPr>
             <a:r>
@@ -3260,7 +3033,7 @@
                 <a:ea typeface="Calibri" pitchFamily="34" charset="-122"/>
                 <a:cs typeface="Calibri" pitchFamily="34" charset="-120"/>
               </a:rPr>
-              <a:t>Mermaid: visual diagram</a:t>
+              <a:t>Importable in VS Code</a:t>
             </a:r>
             <a:endParaRPr lang="en-US" sz="1200" dirty="0"/>
           </a:p>
@@ -3278,24 +3051,6 @@
                 <a:ea typeface="Calibri" pitchFamily="34" charset="-122"/>
                 <a:cs typeface="Calibri" pitchFamily="34" charset="-120"/>
               </a:rPr>
-              <a:t>Importable in VS Code</a:t>
-            </a:r>
-            <a:endParaRPr lang="en-US" sz="1200" dirty="0"/>
-          </a:p>
-          <a:p>
-            <a:pPr marL="342900" indent="-342900">
-              <a:buSzPct val="100000"/>
-              <a:buChar char="•"/>
-            </a:pPr>
-            <a:r>
-              <a:rPr lang="en-US" sz="1200" dirty="0">
-                <a:solidFill>
-                  <a:srgbClr val="1A2440"/>
-                </a:solidFill>
-                <a:latin typeface="Calibri" pitchFamily="34" charset="0"/>
-                <a:ea typeface="Calibri" pitchFamily="34" charset="-122"/>
-                <a:cs typeface="Calibri" pitchFamily="34" charset="-120"/>
-              </a:rPr>
               <a:t>SVG chart download</a:t>
             </a:r>
             <a:endParaRPr lang="en-US" sz="1200" dirty="0"/>
@@ -3323,7 +3078,7 @@
           <a:bodyPr wrap="square" lIns="0" tIns="0" rIns="0" bIns="0" rtlCol="0" anchor="ctr"/>
           <a:lstStyle/>
           <a:p>
-            <a:pPr algn="ctr" indent="0" marL="0">
+            <a:pPr marL="0" indent="0" algn="ctr">
               <a:buNone/>
             </a:pPr>
             <a:r>
@@ -3362,7 +3117,7 @@
           <a:bodyPr wrap="square" lIns="0" tIns="0" rIns="0" bIns="0" rtlCol="0" anchor="ctr"/>
           <a:lstStyle/>
           <a:p>
-            <a:pPr algn="ctr" indent="0" marL="0">
+            <a:pPr marL="0" indent="0" algn="ctr">
               <a:buNone/>
             </a:pPr>
             <a:r>
@@ -3426,7 +3181,7 @@
           <a:bodyPr wrap="square" lIns="0" tIns="0" rIns="0" bIns="0" rtlCol="0" anchor="ctr"/>
           <a:lstStyle/>
           <a:p>
-            <a:pPr algn="ctr" indent="0" marL="0">
+            <a:pPr marL="0" indent="0" algn="ctr">
               <a:buNone/>
             </a:pPr>
             <a:r>
@@ -3460,6 +3215,7 @@
         <a:solidFill>
           <a:srgbClr val="1A2440"/>
         </a:solidFill>
+        <a:effectLst/>
       </p:bgPr>
     </p:bg>
     <p:spTree>
@@ -3497,7 +3253,7 @@
           <a:bodyPr wrap="square" rtlCol="0" anchor="ctr"/>
           <a:lstStyle/>
           <a:p>
-            <a:pPr indent="0" marL="0">
+            <a:pPr marL="0" indent="0">
               <a:buNone/>
             </a:pPr>
             <a:r>
@@ -3524,7 +3280,7 @@
         <p:spPr>
           <a:xfrm>
             <a:off x="365760" y="960120"/>
-            <a:ext cx="3794760" cy="3337560"/>
+            <a:ext cx="3749040" cy="2990088"/>
           </a:xfrm>
           <a:prstGeom prst="rect">
             <a:avLst/>
@@ -3561,11 +3317,11 @@
           <a:bodyPr wrap="square" rtlCol="0" anchor="ctr"/>
           <a:lstStyle/>
           <a:p>
-            <a:pPr indent="0" marL="0">
-              <a:buNone/>
-            </a:pPr>
-            <a:r>
-              <a:rPr lang="en-US" sz="1100" b="1" spc="300" kern="0" dirty="0">
+            <a:pPr marL="0" indent="0">
+              <a:buNone/>
+            </a:pPr>
+            <a:r>
+              <a:rPr lang="en-US" sz="1100" b="1" kern="0" spc="300" dirty="0">
                 <a:solidFill>
                   <a:srgbClr val="009E84"/>
                 </a:solidFill>
@@ -3625,7 +3381,7 @@
           <a:bodyPr wrap="square" rtlCol="0" anchor="ctr"/>
           <a:lstStyle/>
           <a:p>
-            <a:pPr indent="0" marL="0">
+            <a:pPr marL="0" indent="0">
               <a:buNone/>
             </a:pPr>
             <a:r>
@@ -3664,7 +3420,7 @@
           <a:bodyPr wrap="square" rtlCol="0" anchor="ctr"/>
           <a:lstStyle/>
           <a:p>
-            <a:pPr indent="0" marL="0">
+            <a:pPr marL="0" indent="0">
               <a:buNone/>
             </a:pPr>
             <a:r>
@@ -3690,7 +3446,7 @@
         </p:nvSpPr>
         <p:spPr>
           <a:xfrm>
-            <a:off x="594360" y="2121408"/>
+            <a:off x="594360" y="2196845"/>
             <a:ext cx="109728" cy="109728"/>
           </a:xfrm>
           <a:prstGeom prst="ellipse">
@@ -3715,7 +3471,7 @@
         </p:nvSpPr>
         <p:spPr>
           <a:xfrm>
-            <a:off x="804672" y="2011680"/>
+            <a:off x="804672" y="2087117"/>
             <a:ext cx="1371600" cy="329184"/>
           </a:xfrm>
           <a:prstGeom prst="rect">
@@ -3728,7 +3484,7 @@
           <a:bodyPr wrap="square" rtlCol="0" anchor="ctr"/>
           <a:lstStyle/>
           <a:p>
-            <a:pPr indent="0" marL="0">
+            <a:pPr marL="0" indent="0">
               <a:buNone/>
             </a:pPr>
             <a:r>
@@ -3754,7 +3510,7 @@
         </p:nvSpPr>
         <p:spPr>
           <a:xfrm>
-            <a:off x="2240280" y="2011680"/>
+            <a:off x="2240280" y="2087117"/>
             <a:ext cx="1645920" cy="329184"/>
           </a:xfrm>
           <a:prstGeom prst="rect">
@@ -3767,7 +3523,7 @@
           <a:bodyPr wrap="square" rtlCol="0" anchor="ctr"/>
           <a:lstStyle/>
           <a:p>
-            <a:pPr indent="0" marL="0">
+            <a:pPr marL="0" indent="0">
               <a:buNone/>
             </a:pPr>
             <a:r>
@@ -3793,7 +3549,7 @@
         </p:nvSpPr>
         <p:spPr>
           <a:xfrm>
-            <a:off x="594360" y="2624328"/>
+            <a:off x="594360" y="2775205"/>
             <a:ext cx="109728" cy="109728"/>
           </a:xfrm>
           <a:prstGeom prst="ellipse">
@@ -3818,7 +3574,7 @@
         </p:nvSpPr>
         <p:spPr>
           <a:xfrm>
-            <a:off x="804672" y="2514600"/>
+            <a:off x="804672" y="2665477"/>
             <a:ext cx="1371600" cy="329184"/>
           </a:xfrm>
           <a:prstGeom prst="rect">
@@ -3831,7 +3587,7 @@
           <a:bodyPr wrap="square" rtlCol="0" anchor="ctr"/>
           <a:lstStyle/>
           <a:p>
-            <a:pPr indent="0" marL="0">
+            <a:pPr marL="0" indent="0">
               <a:buNone/>
             </a:pPr>
             <a:r>
@@ -3857,7 +3613,7 @@
         </p:nvSpPr>
         <p:spPr>
           <a:xfrm>
-            <a:off x="2240280" y="2514600"/>
+            <a:off x="2240280" y="2665477"/>
             <a:ext cx="1645920" cy="329184"/>
           </a:xfrm>
           <a:prstGeom prst="rect">
@@ -3870,7 +3626,7 @@
           <a:bodyPr wrap="square" rtlCol="0" anchor="ctr"/>
           <a:lstStyle/>
           <a:p>
-            <a:pPr indent="0" marL="0">
+            <a:pPr marL="0" indent="0">
               <a:buNone/>
             </a:pPr>
             <a:r>
@@ -3890,13 +3646,13 @@
       </p:sp>
       <p:sp>
         <p:nvSpPr>
-          <p:cNvPr id="14" name="Shape 12"/>
-          <p:cNvSpPr/>
-          <p:nvPr/>
-        </p:nvSpPr>
-        <p:spPr>
-          <a:xfrm>
-            <a:off x="594360" y="3127248"/>
+          <p:cNvPr id="17" name="Shape 15"/>
+          <p:cNvSpPr/>
+          <p:nvPr/>
+        </p:nvSpPr>
+        <p:spPr>
+          <a:xfrm>
+            <a:off x="594360" y="3360421"/>
             <a:ext cx="109728" cy="109728"/>
           </a:xfrm>
           <a:prstGeom prst="ellipse">
@@ -3915,13 +3671,13 @@
       </p:sp>
       <p:sp>
         <p:nvSpPr>
-          <p:cNvPr id="15" name="Text 13"/>
-          <p:cNvSpPr/>
-          <p:nvPr/>
-        </p:nvSpPr>
-        <p:spPr>
-          <a:xfrm>
-            <a:off x="804672" y="3017520"/>
+          <p:cNvPr id="18" name="Text 16"/>
+          <p:cNvSpPr/>
+          <p:nvPr/>
+        </p:nvSpPr>
+        <p:spPr>
+          <a:xfrm>
+            <a:off x="804672" y="3250693"/>
             <a:ext cx="1371600" cy="329184"/>
           </a:xfrm>
           <a:prstGeom prst="rect">
@@ -3934,7 +3690,7 @@
           <a:bodyPr wrap="square" rtlCol="0" anchor="ctr"/>
           <a:lstStyle/>
           <a:p>
-            <a:pPr indent="0" marL="0">
+            <a:pPr marL="0" indent="0">
               <a:buNone/>
             </a:pPr>
             <a:r>
@@ -3946,7 +3702,7 @@
                 <a:ea typeface="Trebuchet MS" pitchFamily="34" charset="-122"/>
                 <a:cs typeface="Trebuchet MS" pitchFamily="34" charset="-120"/>
               </a:rPr>
-              <a:t>SheetJS</a:t>
+              <a:t>Google Fonts</a:t>
             </a:r>
             <a:endParaRPr lang="en-US" sz="1200" dirty="0"/>
           </a:p>
@@ -3954,13 +3710,13 @@
       </p:sp>
       <p:sp>
         <p:nvSpPr>
-          <p:cNvPr id="16" name="Text 14"/>
-          <p:cNvSpPr/>
-          <p:nvPr/>
-        </p:nvSpPr>
-        <p:spPr>
-          <a:xfrm>
-            <a:off x="2240280" y="3017520"/>
+          <p:cNvPr id="19" name="Text 17"/>
+          <p:cNvSpPr/>
+          <p:nvPr/>
+        </p:nvSpPr>
+        <p:spPr>
+          <a:xfrm>
+            <a:off x="2240280" y="3250693"/>
             <a:ext cx="1645920" cy="329184"/>
           </a:xfrm>
           <a:prstGeom prst="rect">
@@ -3973,7 +3729,7 @@
           <a:bodyPr wrap="square" rtlCol="0" anchor="ctr"/>
           <a:lstStyle/>
           <a:p>
-            <a:pPr indent="0" marL="0">
+            <a:pPr marL="0" indent="0">
               <a:buNone/>
             </a:pPr>
             <a:r>
@@ -3985,7 +3741,7 @@
                 <a:ea typeface="Calibri" pitchFamily="34" charset="-122"/>
                 <a:cs typeface="Calibri" pitchFamily="34" charset="-120"/>
               </a:rPr>
-              <a:t>Excel parsing via CDN</a:t>
+              <a:t>Syne · JetBrains · Outfit</a:t>
             </a:r>
             <a:endParaRPr lang="en-US" sz="1100" dirty="0"/>
           </a:p>
@@ -3993,16 +3749,314 @@
       </p:sp>
       <p:sp>
         <p:nvSpPr>
-          <p:cNvPr id="17" name="Shape 15"/>
-          <p:cNvSpPr/>
-          <p:nvPr/>
-        </p:nvSpPr>
-        <p:spPr>
-          <a:xfrm>
-            <a:off x="594360" y="3630168"/>
-            <a:ext cx="109728" cy="109728"/>
-          </a:xfrm>
-          <a:prstGeom prst="ellipse">
+          <p:cNvPr id="20" name="Shape 18"/>
+          <p:cNvSpPr/>
+          <p:nvPr/>
+        </p:nvSpPr>
+        <p:spPr>
+          <a:xfrm>
+            <a:off x="5029200" y="960120"/>
+            <a:ext cx="3749040" cy="2990088"/>
+          </a:xfrm>
+          <a:prstGeom prst="rect">
+            <a:avLst/>
+          </a:prstGeom>
+          <a:solidFill>
+            <a:srgbClr val="0D1520"/>
+          </a:solidFill>
+          <a:ln w="12700">
+            <a:solidFill>
+              <a:srgbClr val="2A3A55"/>
+            </a:solidFill>
+            <a:prstDash val="solid"/>
+          </a:ln>
+        </p:spPr>
+      </p:sp>
+      <p:sp>
+        <p:nvSpPr>
+          <p:cNvPr id="21" name="Text 19"/>
+          <p:cNvSpPr/>
+          <p:nvPr/>
+        </p:nvSpPr>
+        <p:spPr>
+          <a:xfrm>
+            <a:off x="5257800" y="1078992"/>
+            <a:ext cx="3291840" cy="310896"/>
+          </a:xfrm>
+          <a:prstGeom prst="rect">
+            <a:avLst/>
+          </a:prstGeom>
+          <a:noFill/>
+          <a:ln/>
+        </p:spPr>
+        <p:txBody>
+          <a:bodyPr wrap="square" rtlCol="0" anchor="ctr"/>
+          <a:lstStyle/>
+          <a:p>
+            <a:pPr marL="0" indent="0">
+              <a:buNone/>
+            </a:pPr>
+            <a:r>
+              <a:rPr lang="en-US" sz="1100" b="1" kern="0" spc="300" dirty="0">
+                <a:solidFill>
+                  <a:srgbClr val="009E84"/>
+                </a:solidFill>
+                <a:latin typeface="Calibri" pitchFamily="34" charset="0"/>
+                <a:ea typeface="Calibri" pitchFamily="34" charset="-122"/>
+                <a:cs typeface="Calibri" pitchFamily="34" charset="-120"/>
+              </a:rPr>
+              <a:t>FILE STRUCTURE</a:t>
+            </a:r>
+            <a:endParaRPr lang="en-US" sz="1100" dirty="0"/>
+          </a:p>
+        </p:txBody>
+      </p:sp>
+      <p:sp>
+        <p:nvSpPr>
+          <p:cNvPr id="22" name="Text 20"/>
+          <p:cNvSpPr/>
+          <p:nvPr/>
+        </p:nvSpPr>
+        <p:spPr>
+          <a:xfrm>
+            <a:off x="5257800" y="1508760"/>
+            <a:ext cx="3337560" cy="301752"/>
+          </a:xfrm>
+          <a:prstGeom prst="rect">
+            <a:avLst/>
+          </a:prstGeom>
+          <a:noFill/>
+          <a:ln/>
+        </p:spPr>
+        <p:txBody>
+          <a:bodyPr wrap="square" rtlCol="0" anchor="ctr"/>
+          <a:lstStyle/>
+          <a:p>
+            <a:pPr marL="0" indent="0">
+              <a:buNone/>
+            </a:pPr>
+            <a:r>
+              <a:rPr lang="en-US" sz="1100" b="1" dirty="0">
+                <a:solidFill>
+                  <a:srgbClr val="FFFFFF"/>
+                </a:solidFill>
+                <a:latin typeface="Consolas" pitchFamily="34" charset="0"/>
+                <a:ea typeface="Consolas" pitchFamily="34" charset="-122"/>
+                <a:cs typeface="Consolas" pitchFamily="34" charset="-120"/>
+              </a:rPr>
+              <a:t>simuladores_1/</a:t>
+            </a:r>
+            <a:endParaRPr lang="en-US" sz="1100" dirty="0"/>
+          </a:p>
+        </p:txBody>
+      </p:sp>
+      <p:sp>
+        <p:nvSpPr>
+          <p:cNvPr id="23" name="Text 21"/>
+          <p:cNvSpPr/>
+          <p:nvPr/>
+        </p:nvSpPr>
+        <p:spPr>
+          <a:xfrm>
+            <a:off x="5577840" y="1837944"/>
+            <a:ext cx="3017520" cy="301752"/>
+          </a:xfrm>
+          <a:prstGeom prst="rect">
+            <a:avLst/>
+          </a:prstGeom>
+          <a:noFill/>
+          <a:ln/>
+        </p:spPr>
+        <p:txBody>
+          <a:bodyPr wrap="square" rtlCol="0" anchor="ctr"/>
+          <a:lstStyle/>
+          <a:p>
+            <a:pPr marL="0" indent="0">
+              <a:buNone/>
+            </a:pPr>
+            <a:r>
+              <a:rPr lang="en-US" sz="1100" dirty="0">
+                <a:solidFill>
+                  <a:srgbClr val="A8C0D8"/>
+                </a:solidFill>
+                <a:latin typeface="Consolas" pitchFamily="34" charset="0"/>
+                <a:ea typeface="Consolas" pitchFamily="34" charset="-122"/>
+                <a:cs typeface="Consolas" pitchFamily="34" charset="-120"/>
+              </a:rPr>
+              <a:t>├── delta_radiomics_analyzer.html</a:t>
+            </a:r>
+            <a:endParaRPr lang="en-US" sz="1100" dirty="0"/>
+          </a:p>
+        </p:txBody>
+      </p:sp>
+      <p:sp>
+        <p:nvSpPr>
+          <p:cNvPr id="24" name="Text 22"/>
+          <p:cNvSpPr/>
+          <p:nvPr/>
+        </p:nvSpPr>
+        <p:spPr>
+          <a:xfrm>
+            <a:off x="5577840" y="2167128"/>
+            <a:ext cx="3017520" cy="301752"/>
+          </a:xfrm>
+          <a:prstGeom prst="rect">
+            <a:avLst/>
+          </a:prstGeom>
+          <a:noFill/>
+          <a:ln/>
+        </p:spPr>
+        <p:txBody>
+          <a:bodyPr wrap="square" rtlCol="0" anchor="ctr"/>
+          <a:lstStyle/>
+          <a:p>
+            <a:pPr marL="0" indent="0">
+              <a:buNone/>
+            </a:pPr>
+            <a:r>
+              <a:rPr lang="en-US" sz="1100" dirty="0">
+                <a:solidFill>
+                  <a:srgbClr val="A8C0D8"/>
+                </a:solidFill>
+                <a:latin typeface="Consolas" pitchFamily="34" charset="0"/>
+                <a:ea typeface="Consolas" pitchFamily="34" charset="-122"/>
+                <a:cs typeface="Consolas" pitchFamily="34" charset="-120"/>
+              </a:rPr>
+              <a:t>├── styles.css</a:t>
+            </a:r>
+            <a:endParaRPr lang="en-US" sz="1100" dirty="0"/>
+          </a:p>
+        </p:txBody>
+      </p:sp>
+      <p:sp>
+        <p:nvSpPr>
+          <p:cNvPr id="25" name="Text 23"/>
+          <p:cNvSpPr/>
+          <p:nvPr/>
+        </p:nvSpPr>
+        <p:spPr>
+          <a:xfrm>
+            <a:off x="5577840" y="2496312"/>
+            <a:ext cx="3017520" cy="301752"/>
+          </a:xfrm>
+          <a:prstGeom prst="rect">
+            <a:avLst/>
+          </a:prstGeom>
+          <a:noFill/>
+          <a:ln/>
+        </p:spPr>
+        <p:txBody>
+          <a:bodyPr wrap="square" rtlCol="0" anchor="ctr"/>
+          <a:lstStyle/>
+          <a:p>
+            <a:pPr marL="0" indent="0">
+              <a:buNone/>
+            </a:pPr>
+            <a:r>
+              <a:rPr lang="en-US" sz="1100" dirty="0">
+                <a:solidFill>
+                  <a:srgbClr val="A8C0D8"/>
+                </a:solidFill>
+                <a:latin typeface="Consolas" pitchFamily="34" charset="0"/>
+                <a:ea typeface="Consolas" pitchFamily="34" charset="-122"/>
+                <a:cs typeface="Consolas" pitchFamily="34" charset="-120"/>
+              </a:rPr>
+              <a:t>└── main.js</a:t>
+            </a:r>
+            <a:endParaRPr lang="en-US" sz="1100" dirty="0"/>
+          </a:p>
+        </p:txBody>
+      </p:sp>
+      <p:sp>
+        <p:nvSpPr>
+          <p:cNvPr id="26" name="Text 24"/>
+          <p:cNvSpPr/>
+          <p:nvPr/>
+        </p:nvSpPr>
+        <p:spPr>
+          <a:xfrm>
+            <a:off x="5577840" y="3154680"/>
+            <a:ext cx="3017520" cy="301752"/>
+          </a:xfrm>
+          <a:prstGeom prst="rect">
+            <a:avLst/>
+          </a:prstGeom>
+          <a:noFill/>
+          <a:ln/>
+        </p:spPr>
+        <p:txBody>
+          <a:bodyPr wrap="square" rtlCol="0" anchor="ctr"/>
+          <a:lstStyle/>
+          <a:p>
+            <a:pPr marL="0" indent="0">
+              <a:buNone/>
+            </a:pPr>
+            <a:r>
+              <a:rPr lang="en-US" sz="1100" dirty="0">
+                <a:solidFill>
+                  <a:srgbClr val="6880A8"/>
+                </a:solidFill>
+                <a:latin typeface="Consolas" pitchFamily="34" charset="0"/>
+                <a:ea typeface="Consolas" pitchFamily="34" charset="-122"/>
+                <a:cs typeface="Consolas" pitchFamily="34" charset="-120"/>
+              </a:rPr>
+              <a:t>datos_respondedor.xlsx</a:t>
+            </a:r>
+            <a:endParaRPr lang="en-US" sz="1100" dirty="0"/>
+          </a:p>
+        </p:txBody>
+      </p:sp>
+      <p:sp>
+        <p:nvSpPr>
+          <p:cNvPr id="27" name="Text 25"/>
+          <p:cNvSpPr/>
+          <p:nvPr/>
+        </p:nvSpPr>
+        <p:spPr>
+          <a:xfrm>
+            <a:off x="5577840" y="3483864"/>
+            <a:ext cx="3017520" cy="301752"/>
+          </a:xfrm>
+          <a:prstGeom prst="rect">
+            <a:avLst/>
+          </a:prstGeom>
+          <a:noFill/>
+          <a:ln/>
+        </p:spPr>
+        <p:txBody>
+          <a:bodyPr wrap="square" rtlCol="0" anchor="ctr"/>
+          <a:lstStyle/>
+          <a:p>
+            <a:pPr marL="0" indent="0">
+              <a:buNone/>
+            </a:pPr>
+            <a:r>
+              <a:rPr lang="en-US" sz="1100" dirty="0">
+                <a:solidFill>
+                  <a:srgbClr val="6880A8"/>
+                </a:solidFill>
+                <a:latin typeface="Consolas" pitchFamily="34" charset="0"/>
+                <a:ea typeface="Consolas" pitchFamily="34" charset="-122"/>
+                <a:cs typeface="Consolas" pitchFamily="34" charset="-120"/>
+              </a:rPr>
+              <a:t>datos_no_respondedor.xlsx</a:t>
+            </a:r>
+            <a:endParaRPr lang="en-US" sz="1100" dirty="0"/>
+          </a:p>
+        </p:txBody>
+      </p:sp>
+      <p:sp>
+        <p:nvSpPr>
+          <p:cNvPr id="28" name="Shape 26"/>
+          <p:cNvSpPr/>
+          <p:nvPr/>
+        </p:nvSpPr>
+        <p:spPr>
+          <a:xfrm>
+            <a:off x="0" y="4553712"/>
+            <a:ext cx="9144000" cy="589788"/>
+          </a:xfrm>
+          <a:prstGeom prst="rect">
             <a:avLst/>
           </a:prstGeom>
           <a:solidFill>
@@ -4018,407 +4072,6 @@
       </p:sp>
       <p:sp>
         <p:nvSpPr>
-          <p:cNvPr id="18" name="Text 16"/>
-          <p:cNvSpPr/>
-          <p:nvPr/>
-        </p:nvSpPr>
-        <p:spPr>
-          <a:xfrm>
-            <a:off x="804672" y="3520440"/>
-            <a:ext cx="1371600" cy="329184"/>
-          </a:xfrm>
-          <a:prstGeom prst="rect">
-            <a:avLst/>
-          </a:prstGeom>
-          <a:noFill/>
-          <a:ln/>
-        </p:spPr>
-        <p:txBody>
-          <a:bodyPr wrap="square" rtlCol="0" anchor="ctr"/>
-          <a:lstStyle/>
-          <a:p>
-            <a:pPr indent="0" marL="0">
-              <a:buNone/>
-            </a:pPr>
-            <a:r>
-              <a:rPr lang="en-US" sz="1200" b="1" dirty="0">
-                <a:solidFill>
-                  <a:srgbClr val="FFFFFF"/>
-                </a:solidFill>
-                <a:latin typeface="Trebuchet MS" pitchFamily="34" charset="0"/>
-                <a:ea typeface="Trebuchet MS" pitchFamily="34" charset="-122"/>
-                <a:cs typeface="Trebuchet MS" pitchFamily="34" charset="-120"/>
-              </a:rPr>
-              <a:t>Google Fonts</a:t>
-            </a:r>
-            <a:endParaRPr lang="en-US" sz="1200" dirty="0"/>
-          </a:p>
-        </p:txBody>
-      </p:sp>
-      <p:sp>
-        <p:nvSpPr>
-          <p:cNvPr id="19" name="Text 17"/>
-          <p:cNvSpPr/>
-          <p:nvPr/>
-        </p:nvSpPr>
-        <p:spPr>
-          <a:xfrm>
-            <a:off x="2240280" y="3520440"/>
-            <a:ext cx="1645920" cy="329184"/>
-          </a:xfrm>
-          <a:prstGeom prst="rect">
-            <a:avLst/>
-          </a:prstGeom>
-          <a:noFill/>
-          <a:ln/>
-        </p:spPr>
-        <p:txBody>
-          <a:bodyPr wrap="square" rtlCol="0" anchor="ctr"/>
-          <a:lstStyle/>
-          <a:p>
-            <a:pPr indent="0" marL="0">
-              <a:buNone/>
-            </a:pPr>
-            <a:r>
-              <a:rPr lang="en-US" sz="1100" dirty="0">
-                <a:solidFill>
-                  <a:srgbClr val="A8C0D8"/>
-                </a:solidFill>
-                <a:latin typeface="Calibri" pitchFamily="34" charset="0"/>
-                <a:ea typeface="Calibri" pitchFamily="34" charset="-122"/>
-                <a:cs typeface="Calibri" pitchFamily="34" charset="-120"/>
-              </a:rPr>
-              <a:t>Syne · JetBrains · Outfit</a:t>
-            </a:r>
-            <a:endParaRPr lang="en-US" sz="1100" dirty="0"/>
-          </a:p>
-        </p:txBody>
-      </p:sp>
-      <p:sp>
-        <p:nvSpPr>
-          <p:cNvPr id="20" name="Shape 18"/>
-          <p:cNvSpPr/>
-          <p:nvPr/>
-        </p:nvSpPr>
-        <p:spPr>
-          <a:xfrm>
-            <a:off x="5029200" y="960120"/>
-            <a:ext cx="3749040" cy="3337560"/>
-          </a:xfrm>
-          <a:prstGeom prst="rect">
-            <a:avLst/>
-          </a:prstGeom>
-          <a:solidFill>
-            <a:srgbClr val="0D1520"/>
-          </a:solidFill>
-          <a:ln w="12700">
-            <a:solidFill>
-              <a:srgbClr val="2A3A55"/>
-            </a:solidFill>
-            <a:prstDash val="solid"/>
-          </a:ln>
-        </p:spPr>
-      </p:sp>
-      <p:sp>
-        <p:nvSpPr>
-          <p:cNvPr id="21" name="Text 19"/>
-          <p:cNvSpPr/>
-          <p:nvPr/>
-        </p:nvSpPr>
-        <p:spPr>
-          <a:xfrm>
-            <a:off x="5257800" y="1078992"/>
-            <a:ext cx="3291840" cy="310896"/>
-          </a:xfrm>
-          <a:prstGeom prst="rect">
-            <a:avLst/>
-          </a:prstGeom>
-          <a:noFill/>
-          <a:ln/>
-        </p:spPr>
-        <p:txBody>
-          <a:bodyPr wrap="square" rtlCol="0" anchor="ctr"/>
-          <a:lstStyle/>
-          <a:p>
-            <a:pPr indent="0" marL="0">
-              <a:buNone/>
-            </a:pPr>
-            <a:r>
-              <a:rPr lang="en-US" sz="1100" b="1" spc="300" kern="0" dirty="0">
-                <a:solidFill>
-                  <a:srgbClr val="009E84"/>
-                </a:solidFill>
-                <a:latin typeface="Calibri" pitchFamily="34" charset="0"/>
-                <a:ea typeface="Calibri" pitchFamily="34" charset="-122"/>
-                <a:cs typeface="Calibri" pitchFamily="34" charset="-120"/>
-              </a:rPr>
-              <a:t>FILE STRUCTURE</a:t>
-            </a:r>
-            <a:endParaRPr lang="en-US" sz="1100" dirty="0"/>
-          </a:p>
-        </p:txBody>
-      </p:sp>
-      <p:sp>
-        <p:nvSpPr>
-          <p:cNvPr id="22" name="Text 20"/>
-          <p:cNvSpPr/>
-          <p:nvPr/>
-        </p:nvSpPr>
-        <p:spPr>
-          <a:xfrm>
-            <a:off x="5257800" y="1508760"/>
-            <a:ext cx="3337560" cy="301752"/>
-          </a:xfrm>
-          <a:prstGeom prst="rect">
-            <a:avLst/>
-          </a:prstGeom>
-          <a:noFill/>
-          <a:ln/>
-        </p:spPr>
-        <p:txBody>
-          <a:bodyPr wrap="square" rtlCol="0" anchor="ctr"/>
-          <a:lstStyle/>
-          <a:p>
-            <a:pPr indent="0" marL="0">
-              <a:buNone/>
-            </a:pPr>
-            <a:r>
-              <a:rPr lang="en-US" sz="1100" b="1" dirty="0">
-                <a:solidFill>
-                  <a:srgbClr val="FFFFFF"/>
-                </a:solidFill>
-                <a:latin typeface="Consolas" pitchFamily="34" charset="0"/>
-                <a:ea typeface="Consolas" pitchFamily="34" charset="-122"/>
-                <a:cs typeface="Consolas" pitchFamily="34" charset="-120"/>
-              </a:rPr>
-              <a:t>simuladores_1/</a:t>
-            </a:r>
-            <a:endParaRPr lang="en-US" sz="1100" dirty="0"/>
-          </a:p>
-        </p:txBody>
-      </p:sp>
-      <p:sp>
-        <p:nvSpPr>
-          <p:cNvPr id="23" name="Text 21"/>
-          <p:cNvSpPr/>
-          <p:nvPr/>
-        </p:nvSpPr>
-        <p:spPr>
-          <a:xfrm>
-            <a:off x="5577840" y="1837944"/>
-            <a:ext cx="3017520" cy="301752"/>
-          </a:xfrm>
-          <a:prstGeom prst="rect">
-            <a:avLst/>
-          </a:prstGeom>
-          <a:noFill/>
-          <a:ln/>
-        </p:spPr>
-        <p:txBody>
-          <a:bodyPr wrap="square" rtlCol="0" anchor="ctr"/>
-          <a:lstStyle/>
-          <a:p>
-            <a:pPr indent="0" marL="0">
-              <a:buNone/>
-            </a:pPr>
-            <a:r>
-              <a:rPr lang="en-US" sz="1100" dirty="0">
-                <a:solidFill>
-                  <a:srgbClr val="A8C0D8"/>
-                </a:solidFill>
-                <a:latin typeface="Consolas" pitchFamily="34" charset="0"/>
-                <a:ea typeface="Consolas" pitchFamily="34" charset="-122"/>
-                <a:cs typeface="Consolas" pitchFamily="34" charset="-120"/>
-              </a:rPr>
-              <a:t>├── delta_radiomics_analyzer.html</a:t>
-            </a:r>
-            <a:endParaRPr lang="en-US" sz="1100" dirty="0"/>
-          </a:p>
-        </p:txBody>
-      </p:sp>
-      <p:sp>
-        <p:nvSpPr>
-          <p:cNvPr id="24" name="Text 22"/>
-          <p:cNvSpPr/>
-          <p:nvPr/>
-        </p:nvSpPr>
-        <p:spPr>
-          <a:xfrm>
-            <a:off x="5577840" y="2167128"/>
-            <a:ext cx="3017520" cy="301752"/>
-          </a:xfrm>
-          <a:prstGeom prst="rect">
-            <a:avLst/>
-          </a:prstGeom>
-          <a:noFill/>
-          <a:ln/>
-        </p:spPr>
-        <p:txBody>
-          <a:bodyPr wrap="square" rtlCol="0" anchor="ctr"/>
-          <a:lstStyle/>
-          <a:p>
-            <a:pPr indent="0" marL="0">
-              <a:buNone/>
-            </a:pPr>
-            <a:r>
-              <a:rPr lang="en-US" sz="1100" dirty="0">
-                <a:solidFill>
-                  <a:srgbClr val="A8C0D8"/>
-                </a:solidFill>
-                <a:latin typeface="Consolas" pitchFamily="34" charset="0"/>
-                <a:ea typeface="Consolas" pitchFamily="34" charset="-122"/>
-                <a:cs typeface="Consolas" pitchFamily="34" charset="-120"/>
-              </a:rPr>
-              <a:t>├── styles.css</a:t>
-            </a:r>
-            <a:endParaRPr lang="en-US" sz="1100" dirty="0"/>
-          </a:p>
-        </p:txBody>
-      </p:sp>
-      <p:sp>
-        <p:nvSpPr>
-          <p:cNvPr id="25" name="Text 23"/>
-          <p:cNvSpPr/>
-          <p:nvPr/>
-        </p:nvSpPr>
-        <p:spPr>
-          <a:xfrm>
-            <a:off x="5577840" y="2496312"/>
-            <a:ext cx="3017520" cy="301752"/>
-          </a:xfrm>
-          <a:prstGeom prst="rect">
-            <a:avLst/>
-          </a:prstGeom>
-          <a:noFill/>
-          <a:ln/>
-        </p:spPr>
-        <p:txBody>
-          <a:bodyPr wrap="square" rtlCol="0" anchor="ctr"/>
-          <a:lstStyle/>
-          <a:p>
-            <a:pPr indent="0" marL="0">
-              <a:buNone/>
-            </a:pPr>
-            <a:r>
-              <a:rPr lang="en-US" sz="1100" dirty="0">
-                <a:solidFill>
-                  <a:srgbClr val="A8C0D8"/>
-                </a:solidFill>
-                <a:latin typeface="Consolas" pitchFamily="34" charset="0"/>
-                <a:ea typeface="Consolas" pitchFamily="34" charset="-122"/>
-                <a:cs typeface="Consolas" pitchFamily="34" charset="-120"/>
-              </a:rPr>
-              <a:t>└── main.js</a:t>
-            </a:r>
-            <a:endParaRPr lang="en-US" sz="1100" dirty="0"/>
-          </a:p>
-        </p:txBody>
-      </p:sp>
-      <p:sp>
-        <p:nvSpPr>
-          <p:cNvPr id="26" name="Text 24"/>
-          <p:cNvSpPr/>
-          <p:nvPr/>
-        </p:nvSpPr>
-        <p:spPr>
-          <a:xfrm>
-            <a:off x="5577840" y="3154680"/>
-            <a:ext cx="3017520" cy="301752"/>
-          </a:xfrm>
-          <a:prstGeom prst="rect">
-            <a:avLst/>
-          </a:prstGeom>
-          <a:noFill/>
-          <a:ln/>
-        </p:spPr>
-        <p:txBody>
-          <a:bodyPr wrap="square" rtlCol="0" anchor="ctr"/>
-          <a:lstStyle/>
-          <a:p>
-            <a:pPr indent="0" marL="0">
-              <a:buNone/>
-            </a:pPr>
-            <a:r>
-              <a:rPr lang="en-US" sz="1100" dirty="0">
-                <a:solidFill>
-                  <a:srgbClr val="6880A8"/>
-                </a:solidFill>
-                <a:latin typeface="Consolas" pitchFamily="34" charset="0"/>
-                <a:ea typeface="Consolas" pitchFamily="34" charset="-122"/>
-                <a:cs typeface="Consolas" pitchFamily="34" charset="-120"/>
-              </a:rPr>
-              <a:t>datos_respondedor.xlsx</a:t>
-            </a:r>
-            <a:endParaRPr lang="en-US" sz="1100" dirty="0"/>
-          </a:p>
-        </p:txBody>
-      </p:sp>
-      <p:sp>
-        <p:nvSpPr>
-          <p:cNvPr id="27" name="Text 25"/>
-          <p:cNvSpPr/>
-          <p:nvPr/>
-        </p:nvSpPr>
-        <p:spPr>
-          <a:xfrm>
-            <a:off x="5577840" y="3483864"/>
-            <a:ext cx="3017520" cy="301752"/>
-          </a:xfrm>
-          <a:prstGeom prst="rect">
-            <a:avLst/>
-          </a:prstGeom>
-          <a:noFill/>
-          <a:ln/>
-        </p:spPr>
-        <p:txBody>
-          <a:bodyPr wrap="square" rtlCol="0" anchor="ctr"/>
-          <a:lstStyle/>
-          <a:p>
-            <a:pPr indent="0" marL="0">
-              <a:buNone/>
-            </a:pPr>
-            <a:r>
-              <a:rPr lang="en-US" sz="1100" dirty="0">
-                <a:solidFill>
-                  <a:srgbClr val="6880A8"/>
-                </a:solidFill>
-                <a:latin typeface="Consolas" pitchFamily="34" charset="0"/>
-                <a:ea typeface="Consolas" pitchFamily="34" charset="-122"/>
-                <a:cs typeface="Consolas" pitchFamily="34" charset="-120"/>
-              </a:rPr>
-              <a:t>datos_no_respondedor.xlsx</a:t>
-            </a:r>
-            <a:endParaRPr lang="en-US" sz="1100" dirty="0"/>
-          </a:p>
-        </p:txBody>
-      </p:sp>
-      <p:sp>
-        <p:nvSpPr>
-          <p:cNvPr id="28" name="Shape 26"/>
-          <p:cNvSpPr/>
-          <p:nvPr/>
-        </p:nvSpPr>
-        <p:spPr>
-          <a:xfrm>
-            <a:off x="0" y="4553712"/>
-            <a:ext cx="9144000" cy="589788"/>
-          </a:xfrm>
-          <a:prstGeom prst="rect">
-            <a:avLst/>
-          </a:prstGeom>
-          <a:solidFill>
-            <a:srgbClr val="009E84"/>
-          </a:solidFill>
-          <a:ln w="12700">
-            <a:solidFill>
-              <a:srgbClr val="333333"/>
-            </a:solidFill>
-            <a:prstDash val="solid"/>
-          </a:ln>
-        </p:spPr>
-      </p:sp>
-      <p:sp>
-        <p:nvSpPr>
           <p:cNvPr id="29" name="Text 27"/>
           <p:cNvSpPr/>
           <p:nvPr/>
@@ -4438,7 +4091,7 @@
           <a:bodyPr wrap="square" rtlCol="0" anchor="ctr"/>
           <a:lstStyle/>
           <a:p>
-            <a:pPr algn="ctr" indent="0" marL="0">
+            <a:pPr marL="0" indent="0" algn="ctr">
               <a:buNone/>
             </a:pPr>
             <a:r>
@@ -4757,4 +4410,299 @@
     </a:ext>
   </a:extLst>
 </a:theme>
+</file>
+
+<file path=ppt/theme/theme2.xml><?xml version="1.0" encoding="utf-8"?>
+<a:theme xmlns:a="http://schemas.openxmlformats.org/drawingml/2006/main" name="Tema de Office">
+  <a:themeElements>
+    <a:clrScheme name="Office">
+      <a:dk1>
+        <a:sysClr val="windowText" lastClr="000000"/>
+      </a:dk1>
+      <a:lt1>
+        <a:sysClr val="window" lastClr="FFFFFF"/>
+      </a:lt1>
+      <a:dk2>
+        <a:srgbClr val="44546A"/>
+      </a:dk2>
+      <a:lt2>
+        <a:srgbClr val="E7E6E6"/>
+      </a:lt2>
+      <a:accent1>
+        <a:srgbClr val="4472C4"/>
+      </a:accent1>
+      <a:accent2>
+        <a:srgbClr val="ED7D31"/>
+      </a:accent2>
+      <a:accent3>
+        <a:srgbClr val="A5A5A5"/>
+      </a:accent3>
+      <a:accent4>
+        <a:srgbClr val="FFC000"/>
+      </a:accent4>
+      <a:accent5>
+        <a:srgbClr val="5B9BD5"/>
+      </a:accent5>
+      <a:accent6>
+        <a:srgbClr val="70AD47"/>
+      </a:accent6>
+      <a:hlink>
+        <a:srgbClr val="0563C1"/>
+      </a:hlink>
+      <a:folHlink>
+        <a:srgbClr val="954F72"/>
+      </a:folHlink>
+    </a:clrScheme>
+    <a:fontScheme name="Office">
+      <a:majorFont>
+        <a:latin typeface="Calibri Light" panose="020F0302020204030204"/>
+        <a:ea typeface=""/>
+        <a:cs typeface=""/>
+        <a:font script="Jpan" typeface="游ゴシック Light"/>
+        <a:font script="Hang" typeface="맑은 고딕"/>
+        <a:font script="Hans" typeface="等线 Light"/>
+        <a:font script="Hant" typeface="新細明體"/>
+        <a:font script="Arab" typeface="Times New Roman"/>
+        <a:font script="Hebr" typeface="Times New Roman"/>
+        <a:font script="Thai" typeface="Angsana New"/>
+        <a:font script="Ethi" typeface="Nyala"/>
+        <a:font script="Beng" typeface="Vrinda"/>
+        <a:font script="Gujr" typeface="Shruti"/>
+        <a:font script="Khmr" typeface="MoolBoran"/>
+        <a:font script="Knda" typeface="Tunga"/>
+        <a:font script="Guru" typeface="Raavi"/>
+        <a:font script="Cans" typeface="Euphemia"/>
+        <a:font script="Cher" typeface="Plantagenet Cherokee"/>
+        <a:font script="Yiii" typeface="Microsoft Yi Baiti"/>
+        <a:font script="Tibt" typeface="Microsoft Himalaya"/>
+        <a:font script="Thaa" typeface="MV Boli"/>
+        <a:font script="Deva" typeface="Mangal"/>
+        <a:font script="Telu" typeface="Gautami"/>
+        <a:font script="Taml" typeface="Latha"/>
+        <a:font script="Syrc" typeface="Estrangelo Edessa"/>
+        <a:font script="Orya" typeface="Kalinga"/>
+        <a:font script="Mlym" typeface="Kartika"/>
+        <a:font script="Laoo" typeface="DokChampa"/>
+        <a:font script="Sinh" typeface="Iskoola Pota"/>
+        <a:font script="Mong" typeface="Mongolian Baiti"/>
+        <a:font script="Viet" typeface="Times New Roman"/>
+        <a:font script="Uigh" typeface="Microsoft Uighur"/>
+        <a:font script="Geor" typeface="Sylfaen"/>
+        <a:font script="Armn" typeface="Arial"/>
+        <a:font script="Bugi" typeface="Leelawadee UI"/>
+        <a:font script="Bopo" typeface="Microsoft JhengHei"/>
+        <a:font script="Java" typeface="Javanese Text"/>
+        <a:font script="Lisu" typeface="Segoe UI"/>
+        <a:font script="Mymr" typeface="Myanmar Text"/>
+        <a:font script="Nkoo" typeface="Ebrima"/>
+        <a:font script="Olck" typeface="Nirmala UI"/>
+        <a:font script="Osma" typeface="Ebrima"/>
+        <a:font script="Phag" typeface="Phagspa"/>
+        <a:font script="Syrn" typeface="Estrangelo Edessa"/>
+        <a:font script="Syrj" typeface="Estrangelo Edessa"/>
+        <a:font script="Syre" typeface="Estrangelo Edessa"/>
+        <a:font script="Sora" typeface="Nirmala UI"/>
+        <a:font script="Tale" typeface="Microsoft Tai Le"/>
+        <a:font script="Talu" typeface="Microsoft New Tai Lue"/>
+        <a:font script="Tfng" typeface="Ebrima"/>
+      </a:majorFont>
+      <a:minorFont>
+        <a:latin typeface="Calibri" panose="020F0502020204030204"/>
+        <a:ea typeface=""/>
+        <a:cs typeface=""/>
+        <a:font script="Jpan" typeface="游ゴシック"/>
+        <a:font script="Hang" typeface="맑은 고딕"/>
+        <a:font script="Hans" typeface="等线"/>
+        <a:font script="Hant" typeface="新細明體"/>
+        <a:font script="Arab" typeface="Arial"/>
+        <a:font script="Hebr" typeface="Arial"/>
+        <a:font script="Thai" typeface="Cordia New"/>
+        <a:font script="Ethi" typeface="Nyala"/>
+        <a:font script="Beng" typeface="Vrinda"/>
+        <a:font script="Gujr" typeface="Shruti"/>
+        <a:font script="Khmr" typeface="DaunPenh"/>
+        <a:font script="Knda" typeface="Tunga"/>
+        <a:font script="Guru" typeface="Raavi"/>
+        <a:font script="Cans" typeface="Euphemia"/>
+        <a:font script="Cher" typeface="Plantagenet Cherokee"/>
+        <a:font script="Yiii" typeface="Microsoft Yi Baiti"/>
+        <a:font script="Tibt" typeface="Microsoft Himalaya"/>
+        <a:font script="Thaa" typeface="MV Boli"/>
+        <a:font script="Deva" typeface="Mangal"/>
+        <a:font script="Telu" typeface="Gautami"/>
+        <a:font script="Taml" typeface="Latha"/>
+        <a:font script="Syrc" typeface="Estrangelo Edessa"/>
+        <a:font script="Orya" typeface="Kalinga"/>
+        <a:font script="Mlym" typeface="Kartika"/>
+        <a:font script="Laoo" typeface="DokChampa"/>
+        <a:font script="Sinh" typeface="Iskoola Pota"/>
+        <a:font script="Mong" typeface="Mongolian Baiti"/>
+        <a:font script="Viet" typeface="Arial"/>
+        <a:font script="Uigh" typeface="Microsoft Uighur"/>
+        <a:font script="Geor" typeface="Sylfaen"/>
+        <a:font script="Armn" typeface="Arial"/>
+        <a:font script="Bugi" typeface="Leelawadee UI"/>
+        <a:font script="Bopo" typeface="Microsoft JhengHei"/>
+        <a:font script="Java" typeface="Javanese Text"/>
+        <a:font script="Lisu" typeface="Segoe UI"/>
+        <a:font script="Mymr" typeface="Myanmar Text"/>
+        <a:font script="Nkoo" typeface="Ebrima"/>
+        <a:font script="Olck" typeface="Nirmala UI"/>
+        <a:font script="Osma" typeface="Ebrima"/>
+        <a:font script="Phag" typeface="Phagspa"/>
+        <a:font script="Syrn" typeface="Estrangelo Edessa"/>
+        <a:font script="Syrj" typeface="Estrangelo Edessa"/>
+        <a:font script="Syre" typeface="Estrangelo Edessa"/>
+        <a:font script="Sora" typeface="Nirmala UI"/>
+        <a:font script="Tale" typeface="Microsoft Tai Le"/>
+        <a:font script="Talu" typeface="Microsoft New Tai Lue"/>
+        <a:font script="Tfng" typeface="Ebrima"/>
+      </a:minorFont>
+    </a:fontScheme>
+    <a:fmtScheme name="Office">
+      <a:fillStyleLst>
+        <a:solidFill>
+          <a:schemeClr val="phClr"/>
+        </a:solidFill>
+        <a:gradFill rotWithShape="1">
+          <a:gsLst>
+            <a:gs pos="0">
+              <a:schemeClr val="phClr">
+                <a:lumMod val="110000"/>
+                <a:satMod val="105000"/>
+                <a:tint val="67000"/>
+              </a:schemeClr>
+            </a:gs>
+            <a:gs pos="50000">
+              <a:schemeClr val="phClr">
+                <a:lumMod val="105000"/>
+                <a:satMod val="103000"/>
+                <a:tint val="73000"/>
+              </a:schemeClr>
+            </a:gs>
+            <a:gs pos="100000">
+              <a:schemeClr val="phClr">
+                <a:lumMod val="105000"/>
+                <a:satMod val="109000"/>
+                <a:tint val="81000"/>
+              </a:schemeClr>
+            </a:gs>
+          </a:gsLst>
+          <a:lin ang="5400000" scaled="0"/>
+        </a:gradFill>
+        <a:gradFill rotWithShape="1">
+          <a:gsLst>
+            <a:gs pos="0">
+              <a:schemeClr val="phClr">
+                <a:satMod val="103000"/>
+                <a:lumMod val="102000"/>
+                <a:tint val="94000"/>
+              </a:schemeClr>
+            </a:gs>
+            <a:gs pos="50000">
+              <a:schemeClr val="phClr">
+                <a:satMod val="110000"/>
+                <a:lumMod val="100000"/>
+                <a:shade val="100000"/>
+              </a:schemeClr>
+            </a:gs>
+            <a:gs pos="100000">
+              <a:schemeClr val="phClr">
+                <a:lumMod val="99000"/>
+                <a:satMod val="120000"/>
+                <a:shade val="78000"/>
+              </a:schemeClr>
+            </a:gs>
+          </a:gsLst>
+          <a:lin ang="5400000" scaled="0"/>
+        </a:gradFill>
+      </a:fillStyleLst>
+      <a:lnStyleLst>
+        <a:ln w="6350" cap="flat" cmpd="sng" algn="ctr">
+          <a:solidFill>
+            <a:schemeClr val="phClr"/>
+          </a:solidFill>
+          <a:prstDash val="solid"/>
+          <a:miter lim="800000"/>
+        </a:ln>
+        <a:ln w="12700" cap="flat" cmpd="sng" algn="ctr">
+          <a:solidFill>
+            <a:schemeClr val="phClr"/>
+          </a:solidFill>
+          <a:prstDash val="solid"/>
+          <a:miter lim="800000"/>
+        </a:ln>
+        <a:ln w="19050" cap="flat" cmpd="sng" algn="ctr">
+          <a:solidFill>
+            <a:schemeClr val="phClr"/>
+          </a:solidFill>
+          <a:prstDash val="solid"/>
+          <a:miter lim="800000"/>
+        </a:ln>
+      </a:lnStyleLst>
+      <a:effectStyleLst>
+        <a:effectStyle>
+          <a:effectLst/>
+        </a:effectStyle>
+        <a:effectStyle>
+          <a:effectLst/>
+        </a:effectStyle>
+        <a:effectStyle>
+          <a:effectLst>
+            <a:outerShdw blurRad="57150" dist="19050" dir="5400000" algn="ctr" rotWithShape="0">
+              <a:srgbClr val="000000">
+                <a:alpha val="63000"/>
+              </a:srgbClr>
+            </a:outerShdw>
+          </a:effectLst>
+        </a:effectStyle>
+      </a:effectStyleLst>
+      <a:bgFillStyleLst>
+        <a:solidFill>
+          <a:schemeClr val="phClr"/>
+        </a:solidFill>
+        <a:solidFill>
+          <a:schemeClr val="phClr">
+            <a:tint val="95000"/>
+            <a:satMod val="170000"/>
+          </a:schemeClr>
+        </a:solidFill>
+        <a:gradFill rotWithShape="1">
+          <a:gsLst>
+            <a:gs pos="0">
+              <a:schemeClr val="phClr">
+                <a:tint val="93000"/>
+                <a:satMod val="150000"/>
+                <a:shade val="98000"/>
+                <a:lumMod val="102000"/>
+              </a:schemeClr>
+            </a:gs>
+            <a:gs pos="50000">
+              <a:schemeClr val="phClr">
+                <a:tint val="98000"/>
+                <a:satMod val="130000"/>
+                <a:shade val="90000"/>
+                <a:lumMod val="103000"/>
+              </a:schemeClr>
+            </a:gs>
+            <a:gs pos="100000">
+              <a:schemeClr val="phClr">
+                <a:shade val="63000"/>
+                <a:satMod val="120000"/>
+              </a:schemeClr>
+            </a:gs>
+          </a:gsLst>
+          <a:lin ang="5400000" scaled="0"/>
+        </a:gradFill>
+      </a:bgFillStyleLst>
+    </a:fmtScheme>
+  </a:themeElements>
+  <a:objectDefaults/>
+  <a:extraClrSchemeLst/>
+  <a:extLst>
+    <a:ext uri="{05A4C25C-085E-4340-85A3-A5531E510DB2}">
+      <thm15:themeFamily xmlns:thm15="http://schemas.microsoft.com/office/thememl/2012/main" name="Office Theme" id="{62F939B6-93AF-4DB8-9C6B-D6C7DFDC589F}" vid="{4A3C46E8-61CC-4603-A589-7422A47A8E4A}"/>
+    </a:ext>
+  </a:extLst>
+</a:theme>
 </file>
</xml_diff>